<commit_message>
docs(bms-autosar): update README and presentation for milestone 3
</commit_message>
<xml_diff>
--- a/BMS_AUTOSAR_Code_Generator_Presentation.pptx
+++ b/BMS_AUTOSAR_Code_Generator_Presentation.pptx
@@ -19,6 +19,8 @@
     <p:sldId id="267" r:id="rId18"/>
     <p:sldId id="268" r:id="rId19"/>
     <p:sldId id="269" r:id="rId20"/>
+    <p:sldId id="271" r:id="rId22"/>
+    <p:sldId id="272" r:id="rId23"/>
     <p:sldId id="270" r:id="rId21"/>
   </p:sldIdLst>
   <p:sldSz cx="12191695" cy="6858000" type="screen4x3"/>
@@ -3720,7 +3722,7 @@
               </a:defRPr>
             </a:pPr>
             <a:r>
-              <a:t>• 单元测试：npm run test:unit ✅ 1647 项通过</a:t>
+              <a:t>• 单元测试：npm run test:unit ✅ 1685 项通过</a:t>
             </a:r>
           </a:p>
           <a:p>
@@ -3735,7 +3737,7 @@
               </a:defRPr>
             </a:pPr>
             <a:r>
-              <a:t>• 插件构建：npm run package:vsix ✅ 生成可安装 .vsix 文件（9.1 MB）</a:t>
+              <a:t>• 插件构建：npm run package:vsix ✅ 生成可安装 .vsix 文件（9.09 MB）</a:t>
             </a:r>
           </a:p>
           <a:p>
@@ -4619,6 +4621,182 @@
             </a:pPr>
             <a:r>
               <a:t>欢迎提问与交流</a:t>
+            </a:r>
+          </a:p>
+        </p:txBody>
+      </p:sp>
+    </p:spTree>
+  </p:cSld>
+  <p:clrMapOvr>
+    <a:masterClrMapping/>
+  </p:clrMapOvr>
+</p:sld>
+</file>
+
+<file path=ppt/slides/slide16.xml><?xml version="1.0" encoding="utf-8"?>
+<p:sld xmlns:a="http://schemas.openxmlformats.org/drawingml/2006/main" xmlns:p="http://schemas.openxmlformats.org/presentationml/2006/main" xmlns:r="http://schemas.openxmlformats.org/officeDocument/2006/relationships">
+  <p:cSld>
+    <p:spTree>
+      <p:nvGrpSpPr>
+        <p:cNvPr id="1" name=""/>
+        <p:cNvGrpSpPr/>
+        <p:nvPr/>
+      </p:nvGrpSpPr>
+      <p:grpSpPr/>
+      <p:sp>
+        <p:nvSpPr>
+          <p:cNvPr id="2" name="Title 1"/>
+          <p:cNvSpPr>
+            <a:spLocks noGrp="1"/>
+          </p:cNvSpPr>
+          <p:nvPr>
+            <p:ph type="title"/>
+          </p:nvPr>
+        </p:nvSpPr>
+        <p:spPr/>
+        <p:txBody>
+          <a:bodyPr/>
+          <a:lstStyle/>
+          <a:p>
+            <a:r>
+              <a:t>核心功能 ⑥：知识库工程化升级</a:t>
+            </a:r>
+          </a:p>
+        </p:txBody>
+      </p:sp>
+      <p:sp>
+        <p:nvSpPr>
+          <p:cNvPr id="3" name="Content Placeholder 2"/>
+          <p:cNvSpPr>
+            <a:spLocks noGrp="1"/>
+          </p:cNvSpPr>
+          <p:nvPr>
+            <p:ph idx="1"/>
+          </p:nvPr>
+        </p:nvSpPr>
+        <p:spPr/>
+        <p:txBody>
+          <a:bodyPr/>
+          <a:lstStyle/>
+          <a:p>
+            <a:pPr/>
+            <a:r>
+              <a:t>源文件元数据：导入时记录 sourcePath / sha256 / mtime / size / locations</a:t>
+            </a:r>
+          </a:p>
+          <a:p>
+            <a:pPr/>
+            <a:r>
+              <a:t>增量导入：未变更文件复用旧条目与向量缓存，仅处理新增/修改/删除</a:t>
+            </a:r>
+          </a:p>
+          <a:p>
+            <a:pPr/>
+            <a:r>
+              <a:t>本地向量缓存：embedding 按 contentHash+model 落盘，knowledge.json 不再臃肿</a:t>
+            </a:r>
+          </a:p>
+          <a:p>
+            <a:pPr/>
+            <a:r>
+              <a:t>格式扩展：支持 DBC 解析，PDF 按页、DOCX 按章节返回位置元数据</a:t>
+            </a:r>
+          </a:p>
+          <a:p>
+            <a:pPr/>
+            <a:r>
+              <a:t>ARXML 结构感知 chunk：保留 SHORT-NAME / UUID，提升检索相关性</a:t>
+            </a:r>
+          </a:p>
+          <a:p>
+            <a:pPr/>
+            <a:r>
+              <a:t>BMS 目录 biome check 零诊断，工程质量达到生产级</a:t>
+            </a:r>
+          </a:p>
+        </p:txBody>
+      </p:sp>
+    </p:spTree>
+  </p:cSld>
+  <p:clrMapOvr>
+    <a:masterClrMapping/>
+  </p:clrMapOvr>
+</p:sld>
+</file>
+
+<file path=ppt/slides/slide17.xml><?xml version="1.0" encoding="utf-8"?>
+<p:sld xmlns:a="http://schemas.openxmlformats.org/drawingml/2006/main" xmlns:p="http://schemas.openxmlformats.org/presentationml/2006/main" xmlns:r="http://schemas.openxmlformats.org/officeDocument/2006/relationships">
+  <p:cSld>
+    <p:spTree>
+      <p:nvGrpSpPr>
+        <p:cNvPr id="1" name=""/>
+        <p:cNvGrpSpPr/>
+        <p:nvPr/>
+      </p:nvGrpSpPr>
+      <p:grpSpPr/>
+      <p:sp>
+        <p:nvSpPr>
+          <p:cNvPr id="2" name="Title 1"/>
+          <p:cNvSpPr>
+            <a:spLocks noGrp="1"/>
+          </p:cNvSpPr>
+          <p:nvPr>
+            <p:ph type="title"/>
+          </p:nvPr>
+        </p:nvSpPr>
+        <p:spPr/>
+        <p:txBody>
+          <a:bodyPr/>
+          <a:lstStyle/>
+          <a:p>
+            <a:r>
+              <a:t>核心功能 ⑦：编译集成与发布自动化</a:t>
+            </a:r>
+          </a:p>
+        </p:txBody>
+      </p:sp>
+      <p:sp>
+        <p:nvSpPr>
+          <p:cNvPr id="3" name="Content Placeholder 2"/>
+          <p:cNvSpPr>
+            <a:spLocks noGrp="1"/>
+          </p:cNvSpPr>
+          <p:nvPr>
+            <p:ph idx="1"/>
+          </p:nvPr>
+        </p:nvSpPr>
+        <p:spPr/>
+        <p:txBody>
+          <a:bodyPr/>
+          <a:lstStyle/>
+          <a:p>
+            <a:pPr/>
+            <a:r>
+              <a:t>编译管理器：内置 Appl / Root 工作流，支持多步命令与状态轮询</a:t>
+            </a:r>
+          </a:p>
+          <a:p>
+            <a:pPr/>
+            <a:r>
+              <a:t>配置持久化：workspace/global 自定义 profile，内置配置可覆盖</a:t>
+            </a:r>
+          </a:p>
+          <a:p>
+            <a:pPr/>
+            <a:r>
+              <a:t>快捷键：Cmd/Ctrl+Shift+B 打开编译管理器，Cmd/Ctrl+Shift+G 打开生成器</a:t>
+            </a:r>
+          </a:p>
+          <a:p>
+            <a:pPr/>
+            <a:r>
+              <a:t>activationEvents：BMS 命令触发插件激活，无需先打开侧边栏</a:t>
+            </a:r>
+          </a:p>
+          <a:p>
+            <a:pPr/>
+            <a:r>
+              <a:t>Release-on-tag：推送 v* tag 自动跑测试、打包 VSIX、上传到 GitHub Release</a:t>
             </a:r>
           </a:p>
         </p:txBody>

</xml_diff>